<commit_message>
feat: atualizacao da sessao apresentacao
</commit_message>
<xml_diff>
--- a/Check-point 05.pptx
+++ b/Check-point 05.pptx
@@ -266,7 +266,7 @@
       </p15:sldGuideLst>
     </p:ext>
     <p:ext uri="GoogleSlidesCustomDataVersion2">
-      <go:slidesCustomData xmlns:go="http://customooxmlschemas.google.com/" xmlns:ahyp="http://schemas.microsoft.com/office/drawing/2018/hyperlinkcolor" xmlns:p15="http://schemas.microsoft.com/office/powerpoint/2012/main" xmlns:p14="http://schemas.microsoft.com/office/powerpoint/2010/main" xmlns:com="http://schemas.openxmlformats.org/drawingml/2006/compatibility" xmlns:pvml="urn:schemas-microsoft-com:office:powerpoint" xmlns:v="urn:schemas-microsoft-com:vml" xmlns:o="urn:schemas-microsoft-com:office:office" xmlns:dgm="http://schemas.openxmlformats.org/drawingml/2006/diagram" xmlns:c="http://schemas.openxmlformats.org/drawingml/2006/chart" xmlns:mv="urn:schemas-microsoft-com:mac:vml" xmlns:mc="http://schemas.openxmlformats.org/markup-compatibility/2006" xmlns="" r:id="rId16" roundtripDataSignature="AMtx7mhrT7VuGdyglqceqxtCLOHbAOEI3w=="/>
+      <go:slidesCustomData xmlns="" xmlns:mc="http://schemas.openxmlformats.org/markup-compatibility/2006" xmlns:mv="urn:schemas-microsoft-com:mac:vml" xmlns:c="http://schemas.openxmlformats.org/drawingml/2006/chart" xmlns:dgm="http://schemas.openxmlformats.org/drawingml/2006/diagram" xmlns:o="urn:schemas-microsoft-com:office:office" xmlns:v="urn:schemas-microsoft-com:vml" xmlns:pvml="urn:schemas-microsoft-com:office:powerpoint" xmlns:com="http://schemas.openxmlformats.org/drawingml/2006/compatibility" xmlns:p14="http://schemas.microsoft.com/office/powerpoint/2010/main" xmlns:p15="http://schemas.microsoft.com/office/powerpoint/2012/main" xmlns:ahyp="http://schemas.microsoft.com/office/drawing/2018/hyperlinkcolor" xmlns:go="http://customooxmlschemas.google.com/" r:id="rId16" roundtripDataSignature="AMtx7mhrT7VuGdyglqceqxtCLOHbAOEI3w=="/>
     </p:ext>
   </p:extLst>
 </p:presentation>
@@ -8171,7 +8171,7 @@
               <a:buNone/>
             </a:pPr>
             <a:r>
-              <a:rPr lang="pt-BR">
+              <a:rPr lang="pt-BR" dirty="0">
                 <a:latin typeface="Arial"/>
                 <a:ea typeface="Arial"/>
                 <a:cs typeface="Arial"/>
@@ -8180,11 +8180,11 @@
               <a:t>Copyright © 202</a:t>
             </a:r>
             <a:r>
-              <a:rPr lang="pt-BR"/>
-              <a:t>5</a:t>
+              <a:rPr lang="pt-BR" dirty="0"/>
+              <a:t>5 </a:t>
             </a:r>
             <a:br>
-              <a:rPr lang="pt-BR">
+              <a:rPr lang="pt-BR" dirty="0">
                 <a:latin typeface="Arial"/>
                 <a:ea typeface="Arial"/>
                 <a:cs typeface="Arial"/>
@@ -8192,10 +8192,10 @@
               </a:rPr>
             </a:br>
             <a:r>
-              <a:rPr lang="pt-BR"/>
+              <a:rPr lang="pt-BR" dirty="0"/>
               <a:t>Prof. Lucas Sousa</a:t>
             </a:r>
-            <a:endParaRPr/>
+            <a:endParaRPr dirty="0"/>
           </a:p>
         </p:txBody>
       </p:sp>
@@ -11127,22 +11127,38 @@
               <a:buChar char="●"/>
             </a:pPr>
             <a:r>
-              <a:rPr lang="pt-BR" sz="2100" b="1">
+              <a:rPr lang="pt-BR" sz="2100" b="1" dirty="0">
                 <a:solidFill>
                   <a:srgbClr val="1F1F1F"/>
                 </a:solidFill>
               </a:rPr>
-              <a:t>Hero Section:</a:t>
-            </a:r>
-            <a:r>
-              <a:rPr lang="pt-BR" sz="2100">
+              <a:t>Hero </a:t>
+            </a:r>
+            <a:r>
+              <a:rPr lang="pt-BR" sz="2100" b="1" dirty="0" err="1">
                 <a:solidFill>
                   <a:srgbClr val="1F1F1F"/>
                 </a:solidFill>
               </a:rPr>
+              <a:t>Section</a:t>
+            </a:r>
+            <a:r>
+              <a:rPr lang="pt-BR" sz="2100" b="1" dirty="0">
+                <a:solidFill>
+                  <a:srgbClr val="1F1F1F"/>
+                </a:solidFill>
+              </a:rPr>
+              <a:t>:</a:t>
+            </a:r>
+            <a:r>
+              <a:rPr lang="pt-BR" sz="2100" dirty="0">
+                <a:solidFill>
+                  <a:srgbClr val="1F1F1F"/>
+                </a:solidFill>
+              </a:rPr>
               <a:t> Título chamativo, breve descrição do app, botão de download e imagem de fundo com comida deliciosa.</a:t>
             </a:r>
-            <a:endParaRPr sz="2100">
+            <a:endParaRPr sz="2100" dirty="0">
               <a:solidFill>
                 <a:srgbClr val="1F1F1F"/>
               </a:solidFill>
@@ -11158,7 +11174,7 @@
               </a:spcAft>
               <a:buNone/>
             </a:pPr>
-            <a:endParaRPr sz="2100">
+            <a:endParaRPr sz="2100" dirty="0">
               <a:solidFill>
                 <a:srgbClr val="1F1F1F"/>
               </a:solidFill>
@@ -11179,7 +11195,7 @@
               <a:buChar char="●"/>
             </a:pPr>
             <a:r>
-              <a:rPr lang="pt-BR" sz="2100" b="1">
+              <a:rPr lang="pt-BR" sz="2100" b="1" dirty="0">
                 <a:solidFill>
                   <a:srgbClr val="1F1F1F"/>
                 </a:solidFill>
@@ -11187,14 +11203,14 @@
               <a:t>Apresentação:</a:t>
             </a:r>
             <a:r>
-              <a:rPr lang="pt-BR" sz="2100">
+              <a:rPr lang="pt-BR" sz="2100" dirty="0">
                 <a:solidFill>
                   <a:srgbClr val="1F1F1F"/>
                 </a:solidFill>
               </a:rPr>
               <a:t> Explicar os benefícios do app, como entrega rápida, variedade de restaurantes e pagamento fácil.</a:t>
             </a:r>
-            <a:endParaRPr sz="2100">
+            <a:endParaRPr sz="2100" dirty="0">
               <a:solidFill>
                 <a:srgbClr val="1F1F1F"/>
               </a:solidFill>
@@ -11210,7 +11226,7 @@
               </a:spcAft>
               <a:buNone/>
             </a:pPr>
-            <a:endParaRPr sz="2100">
+            <a:endParaRPr sz="2100" dirty="0">
               <a:solidFill>
                 <a:srgbClr val="1F1F1F"/>
               </a:solidFill>
@@ -11231,7 +11247,7 @@
               <a:buChar char="●"/>
             </a:pPr>
             <a:r>
-              <a:rPr lang="pt-BR" sz="2100" b="1">
+              <a:rPr lang="pt-BR" sz="2100" b="1" dirty="0">
                 <a:solidFill>
                   <a:srgbClr val="1F1F1F"/>
                 </a:solidFill>
@@ -11239,14 +11255,14 @@
               <a:t>Funcionalidades: </a:t>
             </a:r>
             <a:r>
-              <a:rPr lang="pt-BR" sz="2100">
+              <a:rPr lang="pt-BR" sz="2100" dirty="0">
                 <a:solidFill>
                   <a:srgbClr val="1F1F1F"/>
                 </a:solidFill>
               </a:rPr>
               <a:t>Destacar as principais funcionalidades, como busca por tipo de comida, filtros, etc.</a:t>
             </a:r>
-            <a:endParaRPr sz="2100">
+            <a:endParaRPr sz="2100" dirty="0">
               <a:solidFill>
                 <a:srgbClr val="1F1F1F"/>
               </a:solidFill>
@@ -11262,7 +11278,7 @@
               </a:spcAft>
               <a:buNone/>
             </a:pPr>
-            <a:endParaRPr sz="2100">
+            <a:endParaRPr sz="2100" dirty="0">
               <a:solidFill>
                 <a:srgbClr val="1F1F1F"/>
               </a:solidFill>
@@ -11283,7 +11299,7 @@
               <a:buChar char="●"/>
             </a:pPr>
             <a:r>
-              <a:rPr lang="pt-BR" sz="2100" b="1">
+              <a:rPr lang="pt-BR" sz="2100" b="1" dirty="0">
                 <a:solidFill>
                   <a:srgbClr val="1F1F1F"/>
                 </a:solidFill>
@@ -11291,14 +11307,14 @@
               <a:t>Depoimentos:</a:t>
             </a:r>
             <a:r>
-              <a:rPr lang="pt-BR" sz="2100">
+              <a:rPr lang="pt-BR" sz="2100" dirty="0">
                 <a:solidFill>
                   <a:srgbClr val="1F1F1F"/>
                 </a:solidFill>
               </a:rPr>
               <a:t> Mostrar depoimentos de clientes satisfeitos.</a:t>
             </a:r>
-            <a:endParaRPr sz="2100">
+            <a:endParaRPr sz="2100" dirty="0">
               <a:solidFill>
                 <a:srgbClr val="1F1F1F"/>
               </a:solidFill>
@@ -11314,7 +11330,7 @@
               </a:spcAft>
               <a:buNone/>
             </a:pPr>
-            <a:endParaRPr sz="2100">
+            <a:endParaRPr sz="2100" dirty="0">
               <a:solidFill>
                 <a:srgbClr val="1F1F1F"/>
               </a:solidFill>
@@ -11335,7 +11351,7 @@
               <a:buChar char="●"/>
             </a:pPr>
             <a:r>
-              <a:rPr lang="pt-BR" sz="2100" b="1">
+              <a:rPr lang="pt-BR" sz="2100" b="1" dirty="0">
                 <a:solidFill>
                   <a:srgbClr val="1F1F1F"/>
                 </a:solidFill>
@@ -11343,14 +11359,14 @@
               <a:t>Formulário de Contato: </a:t>
             </a:r>
             <a:r>
-              <a:rPr lang="pt-BR" sz="2100">
+              <a:rPr lang="pt-BR" sz="2100" dirty="0">
                 <a:solidFill>
                   <a:srgbClr val="1F1F1F"/>
                 </a:solidFill>
               </a:rPr>
               <a:t>Coletar e-mails para futuras campanhas.</a:t>
             </a:r>
-            <a:endParaRPr sz="2100">
+            <a:endParaRPr sz="2100" dirty="0">
               <a:solidFill>
                 <a:srgbClr val="1F1F1F"/>
               </a:solidFill>
@@ -11366,7 +11382,7 @@
               </a:spcAft>
               <a:buNone/>
             </a:pPr>
-            <a:endParaRPr sz="2100">
+            <a:endParaRPr sz="2100" dirty="0">
               <a:solidFill>
                 <a:srgbClr val="1F1F1F"/>
               </a:solidFill>
@@ -11387,7 +11403,7 @@
               <a:buChar char="●"/>
             </a:pPr>
             <a:r>
-              <a:rPr lang="pt-BR" sz="2100" b="1">
+              <a:rPr lang="pt-BR" sz="2100" b="1" dirty="0">
                 <a:solidFill>
                   <a:srgbClr val="1F1F1F"/>
                 </a:solidFill>
@@ -11395,14 +11411,14 @@
               <a:t>Rodapé: </a:t>
             </a:r>
             <a:r>
-              <a:rPr lang="pt-BR" sz="2100">
+              <a:rPr lang="pt-BR" sz="2100" dirty="0">
                 <a:solidFill>
                   <a:srgbClr val="1F1F1F"/>
                 </a:solidFill>
               </a:rPr>
               <a:t>Informações de contato, links para redes sociais e termos de uso.</a:t>
             </a:r>
-            <a:endParaRPr sz="2100">
+            <a:endParaRPr sz="2100" dirty="0">
               <a:solidFill>
                 <a:srgbClr val="1F1F1F"/>
               </a:solidFill>

</xml_diff>